<commit_message>
chore: remove public publishing references and keep repo private
</commit_message>
<xml_diff>
--- a/KIOT_Campus_Navigation_Presentation.pptx
+++ b/KIOT_Campus_Navigation_Presentation.pptx
@@ -4117,7 +4117,7 @@
               </a:defRPr>
             </a:pPr>
             <a:r>
-              <a:t>•  Advantages: 100% free hosting and deployment ($0 maintenance cost on GitHub Pages without proprietary API bills).</a:t>
+              <a:t>•  Advantages: Zero infrastructure cost, client-side computation running directly in modern web browsers.</a:t>
             </a:r>
           </a:p>
           <a:p>
@@ -4133,7 +4133,7 @@
               </a:defRPr>
             </a:pPr>
             <a:r>
-              <a:t>•  Advantages: Instant client-side computation running directly in the browser; works even in areas with spotty cellular coverage.</a:t>
+              <a:t>•  Advantages: High computational speed; operates reliably even in areas with spotty cellular coverage.</a:t>
             </a:r>
           </a:p>
           <a:p>
@@ -4451,7 +4451,7 @@
               </a:defRPr>
             </a:pPr>
             <a:r>
-              <a:t>•  Achieves institutional sustainability with zero infrastructure costs, high accessibility, and mobile-friendly usability.</a:t>
+              <a:t>•  Achieves institutional sustainability with high accessibility and mobile-friendly usability.</a:t>
             </a:r>
           </a:p>
           <a:p>
@@ -4467,7 +4467,7 @@
               </a:defRPr>
             </a:pPr>
             <a:r>
-              <a:t>•  Successfully hosted, verified, and live on GitHub Pages: https://logajevin.github.io/kiot-campus-nav/.</a:t>
+              <a:t>•  Demonstrates complete operational functionality for the Capstone Project Work.</a:t>
             </a:r>
           </a:p>
         </p:txBody>
@@ -4618,11 +4618,11 @@
               </a:defRPr>
             </a:pPr>
             <a:r>
-              <a:t>Live Web App: https://logajevin.github.io/kiot-campus-nav/</a:t>
+              <a:t>Department of Computer Science and Engineering</a:t>
             </a:r>
             <a:br/>
             <a:r>
-              <a:t>GitHub Repository: https://github.com/Logajevin/kiot-campus-nav</a:t>
+              <a:t>Knowledge Institute of Technology, Salem</a:t>
             </a:r>
           </a:p>
         </p:txBody>
@@ -6088,7 +6088,7 @@
               </a:defRPr>
             </a:pPr>
             <a:r>
-              <a:t>•  Hosting &amp; Deployment: GitHub Pages with automated CI/CD deployment pipeline.</a:t>
+              <a:t>•  Hosting &amp; Deployment: Institutional Web Server / Campus Intranet.</a:t>
             </a:r>
           </a:p>
         </p:txBody>

</xml_diff>